<commit_message>
add stage 3, 4 results to ppt
</commit_message>
<xml_diff>
--- a/slides.pptx
+++ b/slides.pptx
@@ -999,7 +999,7 @@
           <a:p>
             <a:fld id="{5BCAD085-E8A6-8845-BD4E-CB4CCA059FC4}" type="datetimeFigureOut">
               <a:rPr lang="en-US" smtClean="0"/>
-              <a:t>5/2/26</a:t>
+              <a:t>5/3/26</a:t>
             </a:fld>
             <a:endParaRPr lang="en-US"/>
           </a:p>
@@ -1167,7 +1167,7 @@
           <a:p>
             <a:fld id="{5BCAD085-E8A6-8845-BD4E-CB4CCA059FC4}" type="datetimeFigureOut">
               <a:rPr lang="en-US" smtClean="0"/>
-              <a:t>5/2/26</a:t>
+              <a:t>5/3/26</a:t>
             </a:fld>
             <a:endParaRPr lang="en-US"/>
           </a:p>
@@ -1345,7 +1345,7 @@
           <a:p>
             <a:fld id="{5BCAD085-E8A6-8845-BD4E-CB4CCA059FC4}" type="datetimeFigureOut">
               <a:rPr lang="en-US" smtClean="0"/>
-              <a:t>5/2/26</a:t>
+              <a:t>5/3/26</a:t>
             </a:fld>
             <a:endParaRPr lang="en-US"/>
           </a:p>
@@ -1513,7 +1513,7 @@
           <a:p>
             <a:fld id="{5BCAD085-E8A6-8845-BD4E-CB4CCA059FC4}" type="datetimeFigureOut">
               <a:rPr lang="en-US" smtClean="0"/>
-              <a:t>5/2/26</a:t>
+              <a:t>5/3/26</a:t>
             </a:fld>
             <a:endParaRPr lang="en-US"/>
           </a:p>
@@ -1758,7 +1758,7 @@
           <a:p>
             <a:fld id="{5BCAD085-E8A6-8845-BD4E-CB4CCA059FC4}" type="datetimeFigureOut">
               <a:rPr lang="en-US" smtClean="0"/>
-              <a:t>5/2/26</a:t>
+              <a:t>5/3/26</a:t>
             </a:fld>
             <a:endParaRPr lang="en-US"/>
           </a:p>
@@ -2043,7 +2043,7 @@
           <a:p>
             <a:fld id="{5BCAD085-E8A6-8845-BD4E-CB4CCA059FC4}" type="datetimeFigureOut">
               <a:rPr lang="en-US" smtClean="0"/>
-              <a:t>5/2/26</a:t>
+              <a:t>5/3/26</a:t>
             </a:fld>
             <a:endParaRPr lang="en-US"/>
           </a:p>
@@ -2462,7 +2462,7 @@
           <a:p>
             <a:fld id="{5BCAD085-E8A6-8845-BD4E-CB4CCA059FC4}" type="datetimeFigureOut">
               <a:rPr lang="en-US" smtClean="0"/>
-              <a:t>5/2/26</a:t>
+              <a:t>5/3/26</a:t>
             </a:fld>
             <a:endParaRPr lang="en-US"/>
           </a:p>
@@ -2579,7 +2579,7 @@
           <a:p>
             <a:fld id="{5BCAD085-E8A6-8845-BD4E-CB4CCA059FC4}" type="datetimeFigureOut">
               <a:rPr lang="en-US" smtClean="0"/>
-              <a:t>5/2/26</a:t>
+              <a:t>5/3/26</a:t>
             </a:fld>
             <a:endParaRPr lang="en-US"/>
           </a:p>
@@ -2674,7 +2674,7 @@
           <a:p>
             <a:fld id="{5BCAD085-E8A6-8845-BD4E-CB4CCA059FC4}" type="datetimeFigureOut">
               <a:rPr lang="en-US" smtClean="0"/>
-              <a:t>5/2/26</a:t>
+              <a:t>5/3/26</a:t>
             </a:fld>
             <a:endParaRPr lang="en-US"/>
           </a:p>
@@ -2949,7 +2949,7 @@
           <a:p>
             <a:fld id="{5BCAD085-E8A6-8845-BD4E-CB4CCA059FC4}" type="datetimeFigureOut">
               <a:rPr lang="en-US" smtClean="0"/>
-              <a:t>5/2/26</a:t>
+              <a:t>5/3/26</a:t>
             </a:fld>
             <a:endParaRPr lang="en-US"/>
           </a:p>
@@ -3201,7 +3201,7 @@
           <a:p>
             <a:fld id="{5BCAD085-E8A6-8845-BD4E-CB4CCA059FC4}" type="datetimeFigureOut">
               <a:rPr lang="en-US" smtClean="0"/>
-              <a:t>5/2/26</a:t>
+              <a:t>5/3/26</a:t>
             </a:fld>
             <a:endParaRPr lang="en-US"/>
           </a:p>
@@ -3478,7 +3478,7 @@
           <a:p>
             <a:fld id="{5BCAD085-E8A6-8845-BD4E-CB4CCA059FC4}" type="datetimeFigureOut">
               <a:rPr lang="en-US" smtClean="0"/>
-              <a:t>5/2/26</a:t>
+              <a:t>5/3/26</a:t>
             </a:fld>
             <a:endParaRPr lang="en-US"/>
           </a:p>
@@ -7632,7 +7632,7 @@
         </p:nvGraphicFramePr>
         <p:xfrm>
           <a:off x="548640" y="1554480"/>
-          <a:ext cx="11064240" cy="2857500"/>
+          <a:ext cx="11064240" cy="3025140"/>
         </p:xfrm>
         <a:graphic>
           <a:graphicData uri="http://schemas.openxmlformats.org/drawingml/2006/table">
@@ -7729,7 +7729,7 @@
                           </a:solidFill>
                         </a:rPr>
                         <a:t>Stage 2
-(un-prioritised hand)</a:t>
+(random sampling)</a:t>
                       </a:r>
                     </a:p>
                   </a:txBody>
@@ -7775,7 +7775,7 @@
                           </a:solidFill>
                         </a:rPr>
                         <a:t>Stage 4
-(cold-start AL)</a:t>
+(iterative AL · 4×14)</a:t>
                       </a:r>
                     </a:p>
                   </a:txBody>
@@ -7799,7 +7799,7 @@
                     <a:p>
                       <a:pPr algn="l"/>
                       <a:r>
-                        <a:rPr sz="1200">
+                        <a:rPr sz="1100" b="0">
                           <a:solidFill>
                             <a:srgbClr val="2A2A2A"/>
                           </a:solidFill>
@@ -7821,7 +7821,7 @@
                     <a:p>
                       <a:pPr algn="l"/>
                       <a:r>
-                        <a:rPr sz="1200">
+                        <a:rPr sz="1100" b="0">
                           <a:solidFill>
                             <a:srgbClr val="2A2A2A"/>
                           </a:solidFill>
@@ -7843,12 +7843,12 @@
                     <a:p>
                       <a:pPr algn="l"/>
                       <a:r>
-                        <a:rPr sz="1200">
+                        <a:rPr sz="1100" b="0">
                           <a:solidFill>
                             <a:srgbClr val="2A2A2A"/>
                           </a:solidFill>
                         </a:rPr>
-                        <a:t>annotator coverage</a:t>
+                        <a:t>uniform random</a:t>
                       </a:r>
                     </a:p>
                   </a:txBody>
@@ -7865,7 +7865,7 @@
                     <a:p>
                       <a:pPr algn="l"/>
                       <a:r>
-                        <a:rPr sz="1200">
+                        <a:rPr sz="1100" b="0">
                           <a:solidFill>
                             <a:srgbClr val="2A2A2A"/>
                           </a:solidFill>
@@ -7887,12 +7887,12 @@
                     <a:p>
                       <a:pPr algn="l"/>
                       <a:r>
-                        <a:rPr sz="1200">
+                        <a:rPr sz="1100" b="0">
                           <a:solidFill>
                             <a:srgbClr val="2A2A2A"/>
                           </a:solidFill>
                         </a:rPr>
-                        <a:t>pure feature diversity</a:t>
+                        <a:t>uncertainty × div., 4 rounds</a:t>
                       </a:r>
                     </a:p>
                   </a:txBody>
@@ -7916,12 +7916,12 @@
                     <a:p>
                       <a:pPr algn="l"/>
                       <a:r>
-                        <a:rPr sz="1200">
+                        <a:rPr sz="1100" b="0">
                           <a:solidFill>
                             <a:srgbClr val="2A2A2A"/>
                           </a:solidFill>
                         </a:rPr>
-                        <a:t>Pairwise (hp_v on 13)</a:t>
+                        <a:t>hp_val (val-map · 12 pairs)</a:t>
                       </a:r>
                     </a:p>
                   </a:txBody>
@@ -7938,12 +7938,12 @@
                     <a:p>
                       <a:pPr algn="l"/>
                       <a:r>
-                        <a:rPr sz="1200">
+                        <a:rPr sz="1100" b="0">
                           <a:solidFill>
                             <a:srgbClr val="2A2A2A"/>
                           </a:solidFill>
                         </a:rPr>
-                        <a:t>0.615</a:t>
+                        <a:t>0.417 (5/12)</a:t>
                       </a:r>
                     </a:p>
                   </a:txBody>
@@ -7960,12 +7960,12 @@
                     <a:p>
                       <a:pPr algn="l"/>
                       <a:r>
-                        <a:rPr sz="1200">
+                        <a:rPr sz="1100" b="0">
                           <a:solidFill>
                             <a:srgbClr val="2A2A2A"/>
                           </a:solidFill>
                         </a:rPr>
-                        <a:t>0.846</a:t>
+                        <a:t>0.417 (5/12)</a:t>
                       </a:r>
                     </a:p>
                   </a:txBody>
@@ -7982,12 +7982,12 @@
                     <a:p>
                       <a:pPr algn="l"/>
                       <a:r>
-                        <a:rPr sz="1200">
+                        <a:rPr sz="1100" b="1">
                           <a:solidFill>
-                            <a:srgbClr val="2A2A2A"/>
+                            <a:srgbClr val="C0392B"/>
                           </a:solidFill>
                         </a:rPr>
-                        <a:t>[PENDING]</a:t>
+                        <a:t>0.583 (7/12)</a:t>
                       </a:r>
                     </a:p>
                   </a:txBody>
@@ -8004,12 +8004,12 @@
                     <a:p>
                       <a:pPr algn="l"/>
                       <a:r>
-                        <a:rPr sz="1200">
+                        <a:rPr sz="1100" b="1">
                           <a:solidFill>
-                            <a:srgbClr val="2A2A2A"/>
+                            <a:srgbClr val="C0392B"/>
                           </a:solidFill>
                         </a:rPr>
-                        <a:t>[PENDING]</a:t>
+                        <a:t>0.583 (7/12)</a:t>
                       </a:r>
                     </a:p>
                   </a:txBody>
@@ -8033,12 +8033,12 @@
                     <a:p>
                       <a:pPr algn="l"/>
                       <a:r>
-                        <a:rPr sz="1200">
+                        <a:rPr sz="1100" b="0">
                           <a:solidFill>
                             <a:srgbClr val="2A2A2A"/>
                           </a:solidFill>
                         </a:rPr>
-                        <a:t>Exact-match (h-arg top-1, 13)</a:t>
+                        <a:t>DDG argmax_pm1 (val maps 144-147)</a:t>
                       </a:r>
                     </a:p>
                   </a:txBody>
@@ -8055,12 +8055,12 @@
                     <a:p>
                       <a:pPr algn="l"/>
                       <a:r>
-                        <a:rPr sz="1200">
+                        <a:rPr sz="1100" b="0">
                           <a:solidFill>
                             <a:srgbClr val="2A2A2A"/>
                           </a:solidFill>
                         </a:rPr>
-                        <a:t>0.538</a:t>
+                        <a:t>0.565</a:t>
                       </a:r>
                     </a:p>
                   </a:txBody>
@@ -8077,12 +8077,12 @@
                     <a:p>
                       <a:pPr algn="l"/>
                       <a:r>
-                        <a:rPr sz="1200">
+                        <a:rPr sz="1100" b="0">
                           <a:solidFill>
                             <a:srgbClr val="2A2A2A"/>
                           </a:solidFill>
                         </a:rPr>
-                        <a:t>0.615</a:t>
+                        <a:t>0.556</a:t>
                       </a:r>
                     </a:p>
                   </a:txBody>
@@ -8099,12 +8099,12 @@
                     <a:p>
                       <a:pPr algn="l"/>
                       <a:r>
-                        <a:rPr sz="1200">
+                        <a:rPr sz="1100" b="0">
                           <a:solidFill>
                             <a:srgbClr val="2A2A2A"/>
                           </a:solidFill>
                         </a:rPr>
-                        <a:t>[PENDING]</a:t>
+                        <a:t>0.562</a:t>
                       </a:r>
                     </a:p>
                   </a:txBody>
@@ -8121,12 +8121,12 @@
                     <a:p>
                       <a:pPr algn="l"/>
                       <a:r>
-                        <a:rPr sz="1200">
+                        <a:rPr sz="1100" b="0">
                           <a:solidFill>
                             <a:srgbClr val="2A2A2A"/>
                           </a:solidFill>
                         </a:rPr>
-                        <a:t>[PENDING]</a:t>
+                        <a:t>0.541</a:t>
                       </a:r>
                     </a:p>
                   </a:txBody>
@@ -8150,12 +8150,12 @@
                     <a:p>
                       <a:pPr algn="l"/>
                       <a:r>
-                        <a:rPr sz="1200">
+                        <a:rPr sz="1100" b="0">
                           <a:solidFill>
                             <a:srgbClr val="2A2A2A"/>
                           </a:solidFill>
                         </a:rPr>
-                        <a:t>DDG argmax_pm1 (auto val)</a:t>
+                        <a:t>best round (Stage 4 only)</a:t>
                       </a:r>
                     </a:p>
                   </a:txBody>
@@ -8172,12 +8172,12 @@
                     <a:p>
                       <a:pPr algn="l"/>
                       <a:r>
-                        <a:rPr sz="1200">
+                        <a:rPr sz="1100" b="0">
                           <a:solidFill>
                             <a:srgbClr val="2A2A2A"/>
                           </a:solidFill>
                         </a:rPr>
-                        <a:t>0.550</a:t>
+                        <a:t>—</a:t>
                       </a:r>
                     </a:p>
                   </a:txBody>
@@ -8194,12 +8194,12 @@
                     <a:p>
                       <a:pPr algn="l"/>
                       <a:r>
-                        <a:rPr sz="1200">
+                        <a:rPr sz="1100" b="0">
                           <a:solidFill>
                             <a:srgbClr val="2A2A2A"/>
                           </a:solidFill>
                         </a:rPr>
-                        <a:t>0.541</a:t>
+                        <a:t>—</a:t>
                       </a:r>
                     </a:p>
                   </a:txBody>
@@ -8216,12 +8216,12 @@
                     <a:p>
                       <a:pPr algn="l"/>
                       <a:r>
-                        <a:rPr sz="1200">
+                        <a:rPr sz="1100" b="0">
                           <a:solidFill>
                             <a:srgbClr val="2A2A2A"/>
                           </a:solidFill>
                         </a:rPr>
-                        <a:t>[PENDING]</a:t>
+                        <a:t>—</a:t>
                       </a:r>
                     </a:p>
                   </a:txBody>
@@ -8238,12 +8238,12 @@
                     <a:p>
                       <a:pPr algn="l"/>
                       <a:r>
-                        <a:rPr sz="1200">
+                        <a:rPr sz="1100" b="0">
                           <a:solidFill>
                             <a:srgbClr val="2A2A2A"/>
                           </a:solidFill>
                         </a:rPr>
-                        <a:t>[PENDING]</a:t>
+                        <a:t>round 3 (pm1=0.565, hp_val=0.583)</a:t>
                       </a:r>
                     </a:p>
                   </a:txBody>
@@ -8267,12 +8267,12 @@
                     <a:p>
                       <a:pPr algn="l"/>
                       <a:r>
-                        <a:rPr sz="1200">
+                        <a:rPr sz="1100" b="0">
                           <a:solidFill>
                             <a:srgbClr val="2A2A2A"/>
                           </a:solidFill>
                         </a:rPr>
-                        <a:t>DDG top-3 (auto val)</a:t>
+                        <a:t>Train labels used</a:t>
                       </a:r>
                     </a:p>
                   </a:txBody>
@@ -8289,12 +8289,12 @@
                     <a:p>
                       <a:pPr algn="l"/>
                       <a:r>
-                        <a:rPr sz="1200">
+                        <a:rPr sz="1100" b="0">
                           <a:solidFill>
                             <a:srgbClr val="2A2A2A"/>
                           </a:solidFill>
                         </a:rPr>
-                        <a:t>0.578</a:t>
+                        <a:t>0</a:t>
                       </a:r>
                     </a:p>
                   </a:txBody>
@@ -8311,12 +8311,12 @@
                     <a:p>
                       <a:pPr algn="l"/>
                       <a:r>
-                        <a:rPr sz="1200">
+                        <a:rPr sz="1100" b="0">
                           <a:solidFill>
                             <a:srgbClr val="2A2A2A"/>
                           </a:solidFill>
                         </a:rPr>
-                        <a:t>0.559</a:t>
+                        <a:t>56 (random)</a:t>
                       </a:r>
                     </a:p>
                   </a:txBody>
@@ -8333,12 +8333,12 @@
                     <a:p>
                       <a:pPr algn="l"/>
                       <a:r>
-                        <a:rPr sz="1200">
+                        <a:rPr sz="1100" b="0">
                           <a:solidFill>
                             <a:srgbClr val="2A2A2A"/>
                           </a:solidFill>
                         </a:rPr>
-                        <a:t>[PENDING]</a:t>
+                        <a:t>56 (pool AL)</a:t>
                       </a:r>
                     </a:p>
                   </a:txBody>
@@ -8355,12 +8355,12 @@
                     <a:p>
                       <a:pPr algn="l"/>
                       <a:r>
-                        <a:rPr sz="1200">
+                        <a:rPr sz="1100" b="0">
                           <a:solidFill>
                             <a:srgbClr val="2A2A2A"/>
                           </a:solidFill>
                         </a:rPr>
-                        <a:t>[PENDING]</a:t>
+                        <a:t>4 × 14 (iter AL)</a:t>
                       </a:r>
                     </a:p>
                   </a:txBody>
@@ -8384,7 +8384,7 @@
                     <a:p>
                       <a:pPr algn="l"/>
                       <a:r>
-                        <a:rPr sz="1200">
+                        <a:rPr sz="1100" b="0">
                           <a:solidFill>
                             <a:srgbClr val="2A2A2A"/>
                           </a:solidFill>
@@ -8406,7 +8406,7 @@
                     <a:p>
                       <a:pPr algn="l"/>
                       <a:r>
-                        <a:rPr sz="1200">
+                        <a:rPr sz="1100" b="0">
                           <a:solidFill>
                             <a:srgbClr val="2A2A2A"/>
                           </a:solidFill>
@@ -8428,7 +8428,7 @@
                     <a:p>
                       <a:pPr algn="l"/>
                       <a:r>
-                        <a:rPr sz="1200">
+                        <a:rPr sz="1100" b="0">
                           <a:solidFill>
                             <a:srgbClr val="2A2A2A"/>
                           </a:solidFill>
@@ -8450,7 +8450,7 @@
                     <a:p>
                       <a:pPr algn="l"/>
                       <a:r>
-                        <a:rPr sz="1200">
+                        <a:rPr sz="1100" b="0">
                           <a:solidFill>
                             <a:srgbClr val="2A2A2A"/>
                           </a:solidFill>
@@ -8472,12 +8472,12 @@
                     <a:p>
                       <a:pPr algn="l"/>
                       <a:r>
-                        <a:rPr sz="1200">
+                        <a:rPr sz="1100" b="0">
                           <a:solidFill>
                             <a:srgbClr val="2A2A2A"/>
                           </a:solidFill>
                         </a:rPr>
-                        <a:t>≈3</a:t>
+                        <a:t>≈3 (split across rounds)</a:t>
                       </a:r>
                     </a:p>
                   </a:txBody>
@@ -8501,12 +8501,12 @@
                     <a:p>
                       <a:pPr algn="l"/>
                       <a:r>
-                        <a:rPr sz="1200">
+                        <a:rPr sz="1100" b="0">
                           <a:solidFill>
                             <a:srgbClr val="2A2A2A"/>
                           </a:solidFill>
                         </a:rPr>
-                        <a:t>Distinct episodes labelled</a:t>
+                        <a:t>Distinct episodes</a:t>
                       </a:r>
                     </a:p>
                   </a:txBody>
@@ -8523,7 +8523,7 @@
                     <a:p>
                       <a:pPr algn="l"/>
                       <a:r>
-                        <a:rPr sz="1200">
+                        <a:rPr sz="1100" b="0">
                           <a:solidFill>
                             <a:srgbClr val="2A2A2A"/>
                           </a:solidFill>
@@ -8545,12 +8545,12 @@
                     <a:p>
                       <a:pPr algn="l"/>
                       <a:r>
-                        <a:rPr sz="1200">
+                        <a:rPr sz="1100" b="0">
                           <a:solidFill>
                             <a:srgbClr val="2A2A2A"/>
                           </a:solidFill>
                         </a:rPr>
-                        <a:t>28</a:t>
+                        <a:t>≤56 (no cap)</a:t>
                       </a:r>
                     </a:p>
                   </a:txBody>
@@ -8567,12 +8567,12 @@
                     <a:p>
                       <a:pPr algn="l"/>
                       <a:r>
-                        <a:rPr sz="1200">
+                        <a:rPr sz="1100" b="0">
                           <a:solidFill>
                             <a:srgbClr val="2A2A2A"/>
                           </a:solidFill>
                         </a:rPr>
-                        <a:t>≤28 (cap)</a:t>
+                        <a:t>≤28 (cap=2)</a:t>
                       </a:r>
                     </a:p>
                   </a:txBody>
@@ -8589,12 +8589,12 @@
                     <a:p>
                       <a:pPr algn="l"/>
                       <a:r>
-                        <a:rPr sz="1200">
+                        <a:rPr sz="1100" b="0">
                           <a:solidFill>
                             <a:srgbClr val="2A2A2A"/>
                           </a:solidFill>
                         </a:rPr>
-                        <a:t>≤28 (cap)</a:t>
+                        <a:t>≤28 (cap=2)</a:t>
                       </a:r>
                     </a:p>
                   </a:txBody>
@@ -8656,7 +8656,7 @@
         <p:spPr>
           <a:xfrm>
             <a:off x="548640" y="4800600"/>
-            <a:ext cx="11064240" cy="359522"/>
+            <a:ext cx="11064240" cy="2030556"/>
           </a:xfrm>
           <a:prstGeom prst="rect">
             <a:avLst/>
@@ -8671,22 +8671,182 @@
           <a:p>
             <a:pPr>
               <a:lnSpc>
-                <a:spcPct val="125000"/>
+                <a:spcPct val="130000"/>
               </a:lnSpc>
             </a:pPr>
             <a:r>
-              <a:rPr lang="en-US" sz="1500" b="0" dirty="0">
+              <a:rPr sz="1400" dirty="0">
                 <a:solidFill>
                   <a:srgbClr val="2A2A2A"/>
                 </a:solidFill>
               </a:rPr>
-              <a:t>[FILL IN with 2-3 takeaways]</a:t>
+              <a:t>• </a:t>
+            </a:r>
+            <a:r>
+              <a:rPr sz="1400" b="0" dirty="0">
+                <a:solidFill>
+                  <a:srgbClr val="2A2A2A"/>
+                </a:solidFill>
+              </a:rPr>
+              <a:t>Random sampling at fixed budget gives </a:t>
+            </a:r>
+            <a:r>
+              <a:rPr sz="1400" b="1" dirty="0">
+                <a:solidFill>
+                  <a:srgbClr val="C0392B"/>
+                </a:solidFill>
+              </a:rPr>
+              <a:t>zero lift</a:t>
+            </a:r>
+            <a:r>
+              <a:rPr sz="1400" b="0" dirty="0">
+                <a:solidFill>
+                  <a:srgbClr val="2A2A2A"/>
+                </a:solidFill>
+              </a:rPr>
+              <a:t> over auto-only on </a:t>
+            </a:r>
+            <a:r>
+              <a:rPr sz="1400" b="0" dirty="0" err="1">
+                <a:solidFill>
+                  <a:srgbClr val="2A2A2A"/>
+                </a:solidFill>
+              </a:rPr>
+              <a:t>hp_val</a:t>
+            </a:r>
+            <a:r>
+              <a:rPr sz="1400" b="0" dirty="0">
+                <a:solidFill>
+                  <a:srgbClr val="2A2A2A"/>
+                </a:solidFill>
+              </a:rPr>
+              <a:t> (Stage 2 = Stage 1 = 0.417). Just adding human labels without selection priority is not enough.</a:t>
             </a:r>
             <a:endParaRPr sz="1500" b="0" dirty="0">
               <a:solidFill>
                 <a:srgbClr val="2A2A2A"/>
               </a:solidFill>
             </a:endParaRPr>
+          </a:p>
+          <a:p>
+            <a:pPr>
+              <a:lnSpc>
+                <a:spcPct val="130000"/>
+              </a:lnSpc>
+            </a:pPr>
+            <a:r>
+              <a:rPr sz="1400" dirty="0">
+                <a:solidFill>
+                  <a:srgbClr val="2A2A2A"/>
+                </a:solidFill>
+              </a:rPr>
+              <a:t>• </a:t>
+            </a:r>
+            <a:r>
+              <a:rPr sz="1400" b="0" dirty="0">
+                <a:solidFill>
+                  <a:srgbClr val="2A2A2A"/>
+                </a:solidFill>
+              </a:rPr>
+              <a:t>AL with uncertainty × diversity selection: </a:t>
+            </a:r>
+            <a:r>
+              <a:rPr sz="1400" b="1" dirty="0">
+                <a:solidFill>
+                  <a:srgbClr val="C0392B"/>
+                </a:solidFill>
+              </a:rPr>
+              <a:t>+17 pp on </a:t>
+            </a:r>
+            <a:r>
+              <a:rPr sz="1400" b="1" dirty="0" err="1">
+                <a:solidFill>
+                  <a:srgbClr val="C0392B"/>
+                </a:solidFill>
+              </a:rPr>
+              <a:t>hp_val</a:t>
+            </a:r>
+            <a:r>
+              <a:rPr sz="1400" b="0" dirty="0">
+                <a:solidFill>
+                  <a:srgbClr val="2A2A2A"/>
+                </a:solidFill>
+              </a:rPr>
+              <a:t> over random (5/12 → 7/12) at the same 56-label budget. Selection strategy matters more than label volume.</a:t>
+            </a:r>
+          </a:p>
+          <a:p>
+            <a:pPr>
+              <a:lnSpc>
+                <a:spcPct val="130000"/>
+              </a:lnSpc>
+            </a:pPr>
+            <a:r>
+              <a:rPr sz="1400" dirty="0">
+                <a:solidFill>
+                  <a:srgbClr val="2A2A2A"/>
+                </a:solidFill>
+              </a:rPr>
+              <a:t>• </a:t>
+            </a:r>
+            <a:r>
+              <a:rPr sz="1400" b="1" dirty="0">
+                <a:solidFill>
+                  <a:srgbClr val="2A2A2A"/>
+                </a:solidFill>
+              </a:rPr>
+              <a:t>Iterative AL ≈ single-shot AL</a:t>
+            </a:r>
+            <a:r>
+              <a:rPr sz="1400" b="0" dirty="0">
+                <a:solidFill>
+                  <a:srgbClr val="2A2A2A"/>
+                </a:solidFill>
+              </a:rPr>
+              <a:t> at this budget. 4 rounds of 14 labels with model retrained between matches one batch of 56. Engineering the loop did not pay off here.</a:t>
+            </a:r>
+          </a:p>
+          <a:p>
+            <a:pPr>
+              <a:lnSpc>
+                <a:spcPct val="130000"/>
+              </a:lnSpc>
+            </a:pPr>
+            <a:r>
+              <a:rPr sz="1400" dirty="0">
+                <a:solidFill>
+                  <a:srgbClr val="2A2A2A"/>
+                </a:solidFill>
+              </a:rPr>
+              <a:t>• </a:t>
+            </a:r>
+            <a:r>
+              <a:rPr sz="1400" b="0" dirty="0">
+                <a:solidFill>
+                  <a:srgbClr val="2A2A2A"/>
+                </a:solidFill>
+              </a:rPr>
+              <a:t>DDG-aligned ranking </a:t>
+            </a:r>
+            <a:r>
+              <a:rPr sz="1400" b="1" dirty="0">
+                <a:solidFill>
+                  <a:srgbClr val="2A2A2A"/>
+                </a:solidFill>
+                <a:highlight>
+                  <a:srgbClr val="FFFBCC"/>
+                </a:highlight>
+              </a:rPr>
+              <a:t>preserved</a:t>
+            </a:r>
+            <a:r>
+              <a:rPr sz="1400" b="0" dirty="0">
+                <a:solidFill>
+                  <a:srgbClr val="2A2A2A"/>
+                </a:solidFill>
+              </a:rPr>
+              <a:t> across all four stages: argmax_pm1 ∈ [0.541, 0.565].</a:t>
+            </a:r>
           </a:p>
         </p:txBody>
       </p:sp>

</xml_diff>